<commit_message>
Generate pretty html with correct style
</commit_message>
<xml_diff>
--- a/dist/ai-storybook-investor.pptx
+++ b/dist/ai-storybook-investor.pptx
@@ -16,6 +16,8 @@
     <p:sldId id="264" r:id="rId10"/>
     <p:sldId id="265" r:id="rId11"/>
     <p:sldId id="266" r:id="rId12"/>
+    <p:sldId id="267" r:id="rId13"/>
+    <p:sldId id="268" r:id="rId14"/>
   </p:sldIdLst>
   <p:sldSz cx="9144000" cy="5143500" type="screen16x9"/>
   <p:notesSz cx="6858000" cy="9144000"/>
@@ -3110,12 +3112,7 @@
             <p:ph type="title"/>
           </p:nvPr>
         </p:nvSpPr>
-        <p:spPr>
-          <a:xfrm>
-            <a:off x="722313" y="3305176"/>
-            <a:ext cx="7772400" cy="1021556"/>
-          </a:xfrm>
-        </p:spPr>
+        <p:spPr/>
         <p:txBody>
           <a:bodyPr/>
           <a:lstStyle/>
@@ -3126,6 +3123,35 @@
             <a:r>
               <a:rPr/>
               <a:t>AI StoryBook</a:t>
+            </a:r>
+          </a:p>
+        </p:txBody>
+      </p:sp>
+      <p:sp>
+        <p:nvSpPr>
+          <p:cNvPr id="3" name="Content Placeholder 2"/>
+          <p:cNvSpPr>
+            <a:spLocks noGrp="1"/>
+          </p:cNvSpPr>
+          <p:nvPr>
+            <p:ph idx="1"/>
+          </p:nvPr>
+        </p:nvSpPr>
+        <p:spPr/>
+        <p:txBody>
+          <a:bodyPr/>
+          <a:lstStyle/>
+          <a:p>
+            <a:pPr lvl="0" indent="0" marL="0">
+              <a:buNone/>
+            </a:pPr>
+            <a:r>
+              <a:rPr b="1"/>
+              <a:t>[Logo]</a:t>
+            </a:r>
+            <a:r>
+              <a:rPr/>
+              <a:t> ## Illustrate your imaginations to others</a:t>
             </a:r>
           </a:p>
         </p:txBody>
@@ -3154,30 +3180,70 @@
       </p:grpSpPr>
       <p:sp>
         <p:nvSpPr>
-          <p:cNvPr id="2" name="Title 1"/>
-          <p:cNvSpPr>
-            <a:spLocks noGrp="1"/>
-          </p:cNvSpPr>
-          <p:nvPr>
-            <p:ph type="title"/>
-          </p:nvPr>
-        </p:nvSpPr>
-        <p:spPr>
-          <a:xfrm>
-            <a:off x="722313" y="3305176"/>
-            <a:ext cx="7772400" cy="1021556"/>
-          </a:xfrm>
-        </p:spPr>
+          <p:cNvPr id="3" name="Content Placeholder 2"/>
+          <p:cNvSpPr>
+            <a:spLocks noGrp="1"/>
+          </p:cNvSpPr>
+          <p:nvPr>
+            <p:ph idx="1"/>
+          </p:nvPr>
+        </p:nvSpPr>
+        <p:spPr/>
         <p:txBody>
           <a:bodyPr/>
           <a:lstStyle/>
           <a:p>
             <a:pPr lvl="0" indent="0" marL="0">
+              <a:spcBef>
+                <a:spcPts val="3000"/>
+              </a:spcBef>
               <a:buNone/>
             </a:pPr>
             <a:r>
+              <a:rPr b="1"/>
+              <a:t>Roadmap</a:t>
+            </a:r>
+          </a:p>
+          <a:p>
+            <a:pPr lvl="0" indent="0" marL="0">
+              <a:spcBef>
+                <a:spcPts val="3000"/>
+              </a:spcBef>
+              <a:buNone/>
+            </a:pPr>
+            <a:r>
+              <a:rPr b="1"/>
+              <a:t>Short Term</a:t>
+            </a:r>
+          </a:p>
+          <a:p>
+            <a:pPr lvl="0" indent="0" marL="0">
+              <a:buNone/>
+            </a:pPr>
+            <a:r>
               <a:rPr/>
-              <a:t>Thank You!</a:t>
+              <a:t>Public beta, 10+ styles, 20-page chapters, EN↔JP translation.</a:t>
+            </a:r>
+          </a:p>
+          <a:p>
+            <a:pPr lvl="0" indent="0" marL="0">
+              <a:spcBef>
+                <a:spcPts val="3000"/>
+              </a:spcBef>
+              <a:buNone/>
+            </a:pPr>
+            <a:r>
+              <a:rPr b="1"/>
+              <a:t>Long Term</a:t>
+            </a:r>
+          </a:p>
+          <a:p>
+            <a:pPr lvl="0" indent="0" marL="0">
+              <a:buNone/>
+            </a:pPr>
+            <a:r>
+              <a:rPr/>
+              <a:t>Style marketplace, exports, publisher API pilots, early video/animatics.</a:t>
             </a:r>
           </a:p>
         </p:txBody>
@@ -3206,6 +3272,157 @@
       </p:grpSpPr>
       <p:sp>
         <p:nvSpPr>
+          <p:cNvPr id="3" name="Content Placeholder 2"/>
+          <p:cNvSpPr>
+            <a:spLocks noGrp="1"/>
+          </p:cNvSpPr>
+          <p:nvPr>
+            <p:ph idx="1"/>
+          </p:nvPr>
+        </p:nvSpPr>
+        <p:spPr/>
+        <p:txBody>
+          <a:bodyPr/>
+          <a:lstStyle/>
+          <a:p>
+            <a:pPr lvl="0" indent="0" marL="0">
+              <a:spcBef>
+                <a:spcPts val="3000"/>
+              </a:spcBef>
+              <a:buNone/>
+            </a:pPr>
+            <a:r>
+              <a:rPr b="1"/>
+              <a:t>Meet the Team</a:t>
+            </a:r>
+          </a:p>
+          <a:p>
+            <a:pPr lvl="0" indent="0" marL="0">
+              <a:spcBef>
+                <a:spcPts val="3000"/>
+              </a:spcBef>
+              <a:buNone/>
+            </a:pPr>
+            <a:r>
+              <a:rPr b="1"/>
+              <a:t>Abdulazizbek Gainazarov - Data Scientist</a:t>
+            </a:r>
+          </a:p>
+          <a:p>
+            <a:pPr lvl="0" indent="0" marL="0">
+              <a:buNone/>
+            </a:pPr>
+            <a:r>
+              <a:rPr/>
+              <a:t>Work at WizzAir, Bachelor’s Degree in CS.</a:t>
+            </a:r>
+          </a:p>
+          <a:p>
+            <a:pPr lvl="0" indent="0" marL="0">
+              <a:spcBef>
+                <a:spcPts val="3000"/>
+              </a:spcBef>
+              <a:buNone/>
+            </a:pPr>
+            <a:r>
+              <a:rPr b="1"/>
+              <a:t>Bálint Décsi - Data Engineer</a:t>
+            </a:r>
+          </a:p>
+          <a:p>
+            <a:pPr lvl="0" indent="0" marL="0">
+              <a:buNone/>
+            </a:pPr>
+            <a:r>
+              <a:rPr/>
+              <a:t>Work at Deutsche Telekom IT Solutions HU, Master’s degree in Data Science for ML.</a:t>
+            </a:r>
+          </a:p>
+        </p:txBody>
+      </p:sp>
+    </p:spTree>
+  </p:cSld>
+</p:sld>
+</file>
+
+<file path=ppt/slides/slide12.xml><?xml version="1.0" encoding="utf-8"?>
+<p:sld xmlns:a="http://schemas.openxmlformats.org/drawingml/2006/main" xmlns:r="http://schemas.openxmlformats.org/officeDocument/2006/relationships" xmlns:p="http://schemas.openxmlformats.org/presentationml/2006/main">
+  <p:cSld>
+    <p:spTree>
+      <p:nvGrpSpPr>
+        <p:cNvPr id="1" name=""/>
+        <p:cNvGrpSpPr/>
+        <p:nvPr/>
+      </p:nvGrpSpPr>
+      <p:grpSpPr>
+        <a:xfrm>
+          <a:off x="0" y="0"/>
+          <a:ext cx="0" cy="0"/>
+          <a:chOff x="0" y="0"/>
+          <a:chExt cx="0" cy="0"/>
+        </a:xfrm>
+      </p:grpSpPr>
+      <p:sp>
+        <p:nvSpPr>
+          <p:cNvPr id="3" name="Content Placeholder 2"/>
+          <p:cNvSpPr>
+            <a:spLocks noGrp="1"/>
+          </p:cNvSpPr>
+          <p:nvPr>
+            <p:ph idx="1"/>
+          </p:nvPr>
+        </p:nvSpPr>
+        <p:spPr/>
+        <p:txBody>
+          <a:bodyPr/>
+          <a:lstStyle/>
+          <a:p>
+            <a:pPr lvl="0" indent="0" marL="0">
+              <a:spcBef>
+                <a:spcPts val="3000"/>
+              </a:spcBef>
+              <a:buNone/>
+            </a:pPr>
+            <a:r>
+              <a:rPr b="1"/>
+              <a:t>The Ask</a:t>
+            </a:r>
+          </a:p>
+          <a:p>
+            <a:pPr lvl="0" indent="0" marL="1270000">
+              <a:buNone/>
+            </a:pPr>
+            <a:r>
+              <a:rPr sz="2000" b="1"/>
+              <a:t> $15k in API or GPU credits, publisher intros, legal regulations advice. </a:t>
+            </a:r>
+          </a:p>
+        </p:txBody>
+      </p:sp>
+    </p:spTree>
+  </p:cSld>
+</p:sld>
+</file>
+
+<file path=ppt/slides/slide13.xml><?xml version="1.0" encoding="utf-8"?>
+<p:sld xmlns:a="http://schemas.openxmlformats.org/drawingml/2006/main" xmlns:r="http://schemas.openxmlformats.org/officeDocument/2006/relationships" xmlns:p="http://schemas.openxmlformats.org/presentationml/2006/main">
+  <p:cSld>
+    <p:spTree>
+      <p:nvGrpSpPr>
+        <p:cNvPr id="1" name=""/>
+        <p:cNvGrpSpPr/>
+        <p:nvPr/>
+      </p:nvGrpSpPr>
+      <p:grpSpPr>
+        <a:xfrm>
+          <a:off x="0" y="0"/>
+          <a:ext cx="0" cy="0"/>
+          <a:chOff x="0" y="0"/>
+          <a:chExt cx="0" cy="0"/>
+        </a:xfrm>
+      </p:grpSpPr>
+      <p:sp>
+        <p:nvSpPr>
           <p:cNvPr id="2" name="Title 1"/>
           <p:cNvSpPr>
             <a:spLocks noGrp="1"/>
@@ -3224,6 +3441,34 @@
             </a:pPr>
             <a:r>
               <a:rPr/>
+              <a:t>Thank You!</a:t>
+            </a:r>
+          </a:p>
+        </p:txBody>
+      </p:sp>
+      <p:sp>
+        <p:nvSpPr>
+          <p:cNvPr id="3" name="Content Placeholder 2"/>
+          <p:cNvSpPr>
+            <a:spLocks noGrp="1"/>
+          </p:cNvSpPr>
+          <p:nvPr>
+            <p:ph idx="1"/>
+          </p:nvPr>
+        </p:nvSpPr>
+        <p:spPr/>
+        <p:txBody>
+          <a:bodyPr/>
+          <a:lstStyle/>
+          <a:p>
+            <a:pPr lvl="0" indent="0" marL="0">
+              <a:spcBef>
+                <a:spcPts val="3000"/>
+              </a:spcBef>
+              <a:buNone/>
+            </a:pPr>
+            <a:r>
+              <a:rPr b="1"/>
               <a:t>Let’s build the future of storytelling together.</a:t>
             </a:r>
           </a:p>
@@ -3253,12 +3498,12 @@
       </p:grpSpPr>
       <p:sp>
         <p:nvSpPr>
-          <p:cNvPr id="2" name="Title 1"/>
-          <p:cNvSpPr>
-            <a:spLocks noGrp="1"/>
-          </p:cNvSpPr>
-          <p:nvPr>
-            <p:ph type="title"/>
+          <p:cNvPr id="3" name="Content Placeholder 2"/>
+          <p:cNvSpPr>
+            <a:spLocks noGrp="1"/>
+          </p:cNvSpPr>
+          <p:nvPr>
+            <p:ph idx="1"/>
           </p:nvPr>
         </p:nvSpPr>
         <p:spPr/>
@@ -3267,11 +3512,35 @@
           <a:lstStyle/>
           <a:p>
             <a:pPr lvl="0" indent="0" marL="0">
+              <a:spcBef>
+                <a:spcPts val="3000"/>
+              </a:spcBef>
               <a:buNone/>
             </a:pPr>
             <a:r>
+              <a:rPr b="1"/>
+              <a:t>The Problem</a:t>
+            </a:r>
+          </a:p>
+          <a:p>
+            <a:pPr lvl="0"/>
+            <a:r>
               <a:rPr/>
-              <a:t>Illustrate your imaginations to others</a:t>
+              <a:t>Teen manga fans and writers wait 1 week to 1 month per illustrated chapter.</a:t>
+            </a:r>
+          </a:p>
+          <a:p>
+            <a:pPr lvl="0"/>
+            <a:r>
+              <a:rPr/>
+              <a:t>Manual creation is slow, costly, and requires professional skills.</a:t>
+            </a:r>
+          </a:p>
+          <a:p>
+            <a:pPr lvl="0"/>
+            <a:r>
+              <a:rPr/>
+              <a:t>DIY AI tools lack fixed style and long-range character/story consistency.</a:t>
             </a:r>
           </a:p>
         </p:txBody>
@@ -3300,12 +3569,12 @@
       </p:grpSpPr>
       <p:sp>
         <p:nvSpPr>
-          <p:cNvPr id="2" name="Title 1"/>
-          <p:cNvSpPr>
-            <a:spLocks noGrp="1"/>
-          </p:cNvSpPr>
-          <p:nvPr>
-            <p:ph type="title"/>
+          <p:cNvPr id="3" name="Content Placeholder 2"/>
+          <p:cNvSpPr>
+            <a:spLocks noGrp="1"/>
+          </p:cNvSpPr>
+          <p:nvPr>
+            <p:ph idx="1"/>
           </p:nvPr>
         </p:nvSpPr>
         <p:spPr/>
@@ -3314,48 +3583,42 @@
           <a:lstStyle/>
           <a:p>
             <a:pPr lvl="0" indent="0" marL="0">
+              <a:spcBef>
+                <a:spcPts val="3000"/>
+              </a:spcBef>
               <a:buNone/>
             </a:pPr>
             <a:r>
+              <a:rPr b="1"/>
+              <a:t>Our Solution</a:t>
+            </a:r>
+          </a:p>
+          <a:p>
+            <a:pPr lvl="0"/>
+            <a:r>
               <a:rPr/>
-              <a:t>The Problem</a:t>
-            </a:r>
-          </a:p>
-        </p:txBody>
-      </p:sp>
-      <p:sp>
-        <p:nvSpPr>
-          <p:cNvPr id="3" name="Content Placeholder 2"/>
-          <p:cNvSpPr>
-            <a:spLocks noGrp="1"/>
-          </p:cNvSpPr>
-          <p:nvPr>
-            <p:ph idx="1"/>
-          </p:nvPr>
-        </p:nvSpPr>
-        <p:spPr/>
-        <p:txBody>
-          <a:bodyPr/>
-          <a:lstStyle/>
+              <a:t>{‘One-click ranobe-to-manga’: ‘generate 5–20 pages per chapter in minutes.’}</a:t>
+            </a:r>
+          </a:p>
           <a:p>
             <a:pPr lvl="0"/>
             <a:r>
               <a:rPr/>
-              <a:t>Teen manga fans and writers wait 1 week to 1 month per illustrated chapter.</a:t>
+              <a:t>Long-range character and plot consistency across chapters and runs.</a:t>
             </a:r>
           </a:p>
           <a:p>
             <a:pPr lvl="0"/>
             <a:r>
               <a:rPr/>
-              <a:t>Manual creation is slow, costly, and requires professional skills.</a:t>
+              <a:t>Fixed, reusable style packs and story-structure control.</a:t>
             </a:r>
           </a:p>
           <a:p>
             <a:pPr lvl="0"/>
             <a:r>
               <a:rPr/>
-              <a:t>DIY AI tools lack fixed style and long-range character/story consistency.</a:t>
+              <a:t>Built-in paneling, speech bubbles, and right-to-left layout.</a:t>
             </a:r>
           </a:p>
         </p:txBody>
@@ -3384,12 +3647,12 @@
       </p:grpSpPr>
       <p:sp>
         <p:nvSpPr>
-          <p:cNvPr id="2" name="Title 1"/>
-          <p:cNvSpPr>
-            <a:spLocks noGrp="1"/>
-          </p:cNvSpPr>
-          <p:nvPr>
-            <p:ph type="title"/>
+          <p:cNvPr id="3" name="Content Placeholder 2"/>
+          <p:cNvSpPr>
+            <a:spLocks noGrp="1"/>
+          </p:cNvSpPr>
+          <p:nvPr>
+            <p:ph idx="1"/>
           </p:nvPr>
         </p:nvSpPr>
         <p:spPr/>
@@ -3398,55 +3661,14 @@
           <a:lstStyle/>
           <a:p>
             <a:pPr lvl="0" indent="0" marL="0">
+              <a:spcBef>
+                <a:spcPts val="3000"/>
+              </a:spcBef>
               <a:buNone/>
             </a:pPr>
             <a:r>
-              <a:rPr/>
-              <a:t>Our Solution</a:t>
-            </a:r>
-          </a:p>
-        </p:txBody>
-      </p:sp>
-      <p:sp>
-        <p:nvSpPr>
-          <p:cNvPr id="3" name="Content Placeholder 2"/>
-          <p:cNvSpPr>
-            <a:spLocks noGrp="1"/>
-          </p:cNvSpPr>
-          <p:nvPr>
-            <p:ph idx="1"/>
-          </p:nvPr>
-        </p:nvSpPr>
-        <p:spPr/>
-        <p:txBody>
-          <a:bodyPr/>
-          <a:lstStyle/>
-          <a:p>
-            <a:pPr lvl="0"/>
-            <a:r>
-              <a:rPr/>
-              <a:t>{‘One-click ranobe-to-manga’: ‘generate 5–20 pages per chapter in minutes.’}</a:t>
-            </a:r>
-          </a:p>
-          <a:p>
-            <a:pPr lvl="0"/>
-            <a:r>
-              <a:rPr/>
-              <a:t>Long-range character and plot consistency across chapters and runs.</a:t>
-            </a:r>
-          </a:p>
-          <a:p>
-            <a:pPr lvl="0"/>
-            <a:r>
-              <a:rPr/>
-              <a:t>Fixed, reusable style packs and story-structure control.</a:t>
-            </a:r>
-          </a:p>
-          <a:p>
-            <a:pPr lvl="0"/>
-            <a:r>
-              <a:rPr/>
-              <a:t>Built-in paneling, speech bubbles, and right-to-left layout.</a:t>
+              <a:rPr b="1"/>
+              <a:t>Demo 1: Shadow Slave (Manga Style)</a:t>
             </a:r>
           </a:p>
         </p:txBody>
@@ -3475,12 +3697,12 @@
       </p:grpSpPr>
       <p:sp>
         <p:nvSpPr>
-          <p:cNvPr id="2" name="Title 1"/>
-          <p:cNvSpPr>
-            <a:spLocks noGrp="1"/>
-          </p:cNvSpPr>
-          <p:nvPr>
-            <p:ph type="title"/>
+          <p:cNvPr id="3" name="Text Placeholder 2"/>
+          <p:cNvSpPr>
+            <a:spLocks noGrp="1"/>
+          </p:cNvSpPr>
+          <p:nvPr>
+            <p:ph idx="1" type="body"/>
           </p:nvPr>
         </p:nvSpPr>
         <p:spPr/>
@@ -3492,61 +3714,93 @@
               <a:buNone/>
             </a:pPr>
             <a:r>
+              <a:rPr b="1"/>
+              <a:t>Input</a:t>
+            </a:r>
+          </a:p>
+          <a:p>
+            <a:pPr lvl="0" indent="0" marL="0">
+              <a:buNone/>
+            </a:pPr>
+            <a:r>
+              <a:rPr i="1"/>
+              <a:t>Text:</a:t>
+            </a:r>
+            <a:r>
               <a:rPr/>
-              <a:t>Market Opportunity</a:t>
-            </a:r>
-          </a:p>
-        </p:txBody>
-      </p:sp>
-      <p:sp>
-        <p:nvSpPr>
-          <p:cNvPr id="3" name="Content Placeholder 2"/>
-          <p:cNvSpPr>
-            <a:spLocks noGrp="1"/>
-          </p:cNvSpPr>
-          <p:nvPr>
-            <p:ph idx="1"/>
-          </p:nvPr>
-        </p:nvSpPr>
-        <p:spPr/>
-        <p:txBody>
-          <a:bodyPr/>
-          <a:lstStyle/>
-          <a:p>
-            <a:pPr lvl="0"/>
+              <a:t> “A frail-looking young man with pale skin and dark circles…”</a:t>
+            </a:r>
+          </a:p>
+          <a:p>
+            <a:pPr lvl="0" indent="0" marL="0">
+              <a:buNone/>
+            </a:pPr>
+            <a:r>
+              <a:rPr i="1"/>
+              <a:t>Image:</a:t>
+            </a:r>
+            <a:r>
+              <a:rPr/>
+              <a:t> </a:t>
+            </a:r>
+          </a:p>
+        </p:txBody>
+      </p:sp>
+      <p:sp>
+        <p:nvSpPr>
+          <p:cNvPr id="5" name="Text Placeholder 4"/>
+          <p:cNvSpPr>
+            <a:spLocks noGrp="1"/>
+          </p:cNvSpPr>
+          <p:nvPr>
+            <p:ph idx="3" sz="quarter" type="body"/>
+          </p:nvPr>
+        </p:nvSpPr>
+        <p:spPr/>
+        <p:txBody>
+          <a:bodyPr/>
+          <a:lstStyle/>
+          <a:p>
+            <a:pPr lvl="0" indent="0" marL="0">
+              <a:buNone/>
+            </a:pPr>
             <a:r>
               <a:rPr b="1"/>
-              <a:t>TAM:</a:t>
-            </a:r>
-            <a:r>
-              <a:rPr/>
-              <a:t> $16–20B (Global B2C creators/fans + B2B small publishers)</a:t>
-            </a:r>
-          </a:p>
-          <a:p>
-            <a:pPr lvl="0"/>
-            <a:r>
-              <a:rPr b="1"/>
-              <a:t>SAM:</a:t>
-            </a:r>
-            <a:r>
-              <a:rPr/>
-              <a:t> $1.5–2.5B</a:t>
-            </a:r>
-          </a:p>
-          <a:p>
-            <a:pPr lvl="0"/>
-            <a:r>
-              <a:rPr b="1"/>
-              <a:t>SOM:</a:t>
-            </a:r>
-            <a:r>
-              <a:rPr/>
-              <a:t> $40–60M (3-yr reachable)</a:t>
-            </a:r>
-          </a:p>
-        </p:txBody>
-      </p:sp>
+              <a:t>Output</a:t>
+            </a:r>
+          </a:p>
+        </p:txBody>
+      </p:sp>
+      <p:pic>
+        <p:nvPicPr>
+          <p:cNvPr descr="assets/comics/manga.pdf" id="0" name="Picture 1"/>
+          <p:cNvPicPr>
+            <a:picLocks noGrp="1" noChangeAspect="1"/>
+          </p:cNvPicPr>
+          <p:nvPr/>
+        </p:nvPicPr>
+        <p:blipFill>
+          <a:blip r:embed="rId2"/>
+          <a:stretch>
+            <a:fillRect/>
+          </a:stretch>
+        </p:blipFill>
+        <p:spPr bwMode="auto">
+          <a:xfrm>
+            <a:off x="5676900" y="1625600"/>
+            <a:ext cx="1968500" cy="2959100"/>
+          </a:xfrm>
+          <a:prstGeom prst="rect">
+            <a:avLst/>
+          </a:prstGeom>
+          <a:noFill/>
+          <a:ln w="9525">
+            <a:noFill/>
+            <a:headEnd/>
+            <a:tailEnd/>
+          </a:ln>
+        </p:spPr>
+      </p:pic>
     </p:spTree>
   </p:cSld>
 </p:sld>
@@ -3571,12 +3825,12 @@
       </p:grpSpPr>
       <p:sp>
         <p:nvSpPr>
-          <p:cNvPr id="2" name="Title 1"/>
-          <p:cNvSpPr>
-            <a:spLocks noGrp="1"/>
-          </p:cNvSpPr>
-          <p:nvPr>
-            <p:ph type="title"/>
+          <p:cNvPr id="3" name="Content Placeholder 2"/>
+          <p:cNvSpPr>
+            <a:spLocks noGrp="1"/>
+          </p:cNvSpPr>
+          <p:nvPr>
+            <p:ph idx="1"/>
           </p:nvPr>
         </p:nvSpPr>
         <p:spPr/>
@@ -3585,41 +3839,14 @@
           <a:lstStyle/>
           <a:p>
             <a:pPr lvl="0" indent="0" marL="0">
+              <a:spcBef>
+                <a:spcPts val="3000"/>
+              </a:spcBef>
               <a:buNone/>
             </a:pPr>
             <a:r>
-              <a:rPr/>
-              <a:t>Business Model</a:t>
-            </a:r>
-          </a:p>
-        </p:txBody>
-      </p:sp>
-      <p:sp>
-        <p:nvSpPr>
-          <p:cNvPr id="3" name="Content Placeholder 2"/>
-          <p:cNvSpPr>
-            <a:spLocks noGrp="1"/>
-          </p:cNvSpPr>
-          <p:nvPr>
-            <p:ph idx="1"/>
-          </p:nvPr>
-        </p:nvSpPr>
-        <p:spPr/>
-        <p:txBody>
-          <a:bodyPr/>
-          <a:lstStyle/>
-          <a:p>
-            <a:pPr lvl="0"/>
-            <a:r>
-              <a:rPr/>
-              <a:t>{‘Pay-per-chapter’: ‘$2.99 (5 pages), $9.99 (20 pages).’}</a:t>
-            </a:r>
-          </a:p>
-          <a:p>
-            <a:pPr lvl="0"/>
-            <a:r>
-              <a:rPr/>
-              <a:t>Marketplace for style packs and publisher revenue sharing/licensing.</a:t>
+              <a:rPr b="1"/>
+              <a:t>Demo 2: The Boy and the Magic Van (Children’s Book)</a:t>
             </a:r>
           </a:p>
         </p:txBody>
@@ -3648,12 +3875,12 @@
       </p:grpSpPr>
       <p:sp>
         <p:nvSpPr>
-          <p:cNvPr id="2" name="Title 1"/>
-          <p:cNvSpPr>
-            <a:spLocks noGrp="1"/>
-          </p:cNvSpPr>
-          <p:nvPr>
-            <p:ph type="title"/>
+          <p:cNvPr id="3" name="Text Placeholder 2"/>
+          <p:cNvSpPr>
+            <a:spLocks noGrp="1"/>
+          </p:cNvSpPr>
+          <p:nvPr>
+            <p:ph idx="1" type="body"/>
           </p:nvPr>
         </p:nvSpPr>
         <p:spPr/>
@@ -3665,70 +3892,93 @@
               <a:buNone/>
             </a:pPr>
             <a:r>
+              <a:rPr b="1"/>
+              <a:t>Input</a:t>
+            </a:r>
+          </a:p>
+          <a:p>
+            <a:pPr lvl="0" indent="0" marL="0">
+              <a:buNone/>
+            </a:pPr>
+            <a:r>
+              <a:rPr i="1"/>
+              <a:t>Text:</a:t>
+            </a:r>
+            <a:r>
               <a:rPr/>
-              <a:t>Roadmap</a:t>
-            </a:r>
-          </a:p>
-        </p:txBody>
-      </p:sp>
-      <p:sp>
-        <p:nvSpPr>
-          <p:cNvPr id="3" name="Content Placeholder 2"/>
-          <p:cNvSpPr>
-            <a:spLocks noGrp="1"/>
-          </p:cNvSpPr>
-          <p:nvPr>
-            <p:ph idx="1"/>
-          </p:nvPr>
-        </p:nvSpPr>
-        <p:spPr/>
-        <p:txBody>
-          <a:bodyPr/>
-          <a:lstStyle/>
+              <a:t> “Misi found an old, blue van in a dusty, cobweb‑filled garage…”</a:t>
+            </a:r>
+          </a:p>
           <a:p>
             <a:pPr lvl="0" indent="0" marL="0">
-              <a:spcBef>
-                <a:spcPts val="3000"/>
-              </a:spcBef>
               <a:buNone/>
             </a:pPr>
             <a:r>
+              <a:rPr i="1"/>
+              <a:t>Image:</a:t>
+            </a:r>
+            <a:r>
+              <a:rPr/>
+              <a:t> </a:t>
+            </a:r>
+          </a:p>
+        </p:txBody>
+      </p:sp>
+      <p:sp>
+        <p:nvSpPr>
+          <p:cNvPr id="5" name="Text Placeholder 4"/>
+          <p:cNvSpPr>
+            <a:spLocks noGrp="1"/>
+          </p:cNvSpPr>
+          <p:nvPr>
+            <p:ph idx="3" sz="quarter" type="body"/>
+          </p:nvPr>
+        </p:nvSpPr>
+        <p:spPr/>
+        <p:txBody>
+          <a:bodyPr/>
+          <a:lstStyle/>
+          <a:p>
+            <a:pPr lvl="0" indent="0" marL="0">
+              <a:buNone/>
+            </a:pPr>
+            <a:r>
               <a:rPr b="1"/>
-              <a:t>Short Term</a:t>
-            </a:r>
-          </a:p>
-          <a:p>
-            <a:pPr lvl="0" indent="0" marL="0">
-              <a:buNone/>
-            </a:pPr>
-            <a:r>
-              <a:rPr/>
-              <a:t>Public beta, 10+ styles, 20-page chapters, EN↔JP translation.</a:t>
-            </a:r>
-          </a:p>
-          <a:p>
-            <a:pPr lvl="0" indent="0" marL="0">
-              <a:spcBef>
-                <a:spcPts val="3000"/>
-              </a:spcBef>
-              <a:buNone/>
-            </a:pPr>
-            <a:r>
-              <a:rPr b="1"/>
-              <a:t>Long Term</a:t>
-            </a:r>
-          </a:p>
-          <a:p>
-            <a:pPr lvl="0" indent="0" marL="0">
-              <a:buNone/>
-            </a:pPr>
-            <a:r>
-              <a:rPr/>
-              <a:t>Style marketplace, exports, publisher API pilots, early video/animatics.</a:t>
-            </a:r>
-          </a:p>
-        </p:txBody>
-      </p:sp>
+              <a:t>Output</a:t>
+            </a:r>
+          </a:p>
+        </p:txBody>
+      </p:sp>
+      <p:pic>
+        <p:nvPicPr>
+          <p:cNvPr descr="assets/comics/children_book_page_1.png" id="0" name="Picture 1"/>
+          <p:cNvPicPr>
+            <a:picLocks noGrp="1" noChangeAspect="1"/>
+          </p:cNvPicPr>
+          <p:nvPr/>
+        </p:nvPicPr>
+        <p:blipFill>
+          <a:blip r:embed="rId2"/>
+          <a:stretch>
+            <a:fillRect/>
+          </a:stretch>
+        </p:blipFill>
+        <p:spPr bwMode="auto">
+          <a:xfrm>
+            <a:off x="5397500" y="1625600"/>
+            <a:ext cx="2501900" cy="2959100"/>
+          </a:xfrm>
+          <a:prstGeom prst="rect">
+            <a:avLst/>
+          </a:prstGeom>
+          <a:noFill/>
+          <a:ln w="9525">
+            <a:noFill/>
+            <a:headEnd/>
+            <a:tailEnd/>
+          </a:ln>
+        </p:spPr>
+      </p:pic>
     </p:spTree>
   </p:cSld>
 </p:sld>
@@ -3753,31 +4003,6 @@
       </p:grpSpPr>
       <p:sp>
         <p:nvSpPr>
-          <p:cNvPr id="2" name="Title 1"/>
-          <p:cNvSpPr>
-            <a:spLocks noGrp="1"/>
-          </p:cNvSpPr>
-          <p:nvPr>
-            <p:ph type="title"/>
-          </p:nvPr>
-        </p:nvSpPr>
-        <p:spPr/>
-        <p:txBody>
-          <a:bodyPr/>
-          <a:lstStyle/>
-          <a:p>
-            <a:pPr lvl="0" indent="0" marL="0">
-              <a:buNone/>
-            </a:pPr>
-            <a:r>
-              <a:rPr/>
-              <a:t>Meet the Team</a:t>
-            </a:r>
-          </a:p>
-        </p:txBody>
-      </p:sp>
-      <p:sp>
-        <p:nvSpPr>
           <p:cNvPr id="3" name="Content Placeholder 2"/>
           <p:cNvSpPr>
             <a:spLocks noGrp="1"/>
@@ -3799,37 +4024,40 @@
             </a:pPr>
             <a:r>
               <a:rPr b="1"/>
-              <a:t>Abdulazizbek Gainazarov - Data Scientist</a:t>
-            </a:r>
-          </a:p>
-          <a:p>
-            <a:pPr lvl="0" indent="0" marL="0">
-              <a:buNone/>
-            </a:pPr>
+              <a:t>Market Opportunity</a:t>
+            </a:r>
+          </a:p>
+          <a:p>
+            <a:pPr lvl="0"/>
+            <a:r>
+              <a:rPr b="1"/>
+              <a:t>TAM:</a:t>
+            </a:r>
             <a:r>
               <a:rPr/>
-              <a:t>Work at WizzAir, Bachelor’s Degree in CS.</a:t>
-            </a:r>
-          </a:p>
-          <a:p>
-            <a:pPr lvl="0" indent="0" marL="0">
-              <a:spcBef>
-                <a:spcPts val="3000"/>
-              </a:spcBef>
-              <a:buNone/>
-            </a:pPr>
+              <a:t> $16–20B (Global B2C creators/fans + B2B small publishers)</a:t>
+            </a:r>
+          </a:p>
+          <a:p>
+            <a:pPr lvl="0"/>
             <a:r>
               <a:rPr b="1"/>
-              <a:t>Bálint Décsi - Data Engineer</a:t>
-            </a:r>
-          </a:p>
-          <a:p>
-            <a:pPr lvl="0" indent="0" marL="0">
-              <a:buNone/>
-            </a:pPr>
+              <a:t>SAM:</a:t>
+            </a:r>
             <a:r>
               <a:rPr/>
-              <a:t>Work at Deutsche Telekom IT Solutions HU, Master’s degree in Data Science for ML.</a:t>
+              <a:t> $1.5–2.5B</a:t>
+            </a:r>
+          </a:p>
+          <a:p>
+            <a:pPr lvl="0"/>
+            <a:r>
+              <a:rPr b="1"/>
+              <a:t>SOM:</a:t>
+            </a:r>
+            <a:r>
+              <a:rPr/>
+              <a:t> $40–60M (3-yr reachable)</a:t>
             </a:r>
           </a:p>
         </p:txBody>
@@ -3858,12 +4086,12 @@
       </p:grpSpPr>
       <p:sp>
         <p:nvSpPr>
-          <p:cNvPr id="2" name="Title 1"/>
-          <p:cNvSpPr>
-            <a:spLocks noGrp="1"/>
-          </p:cNvSpPr>
-          <p:nvPr>
-            <p:ph type="title"/>
+          <p:cNvPr id="3" name="Content Placeholder 2"/>
+          <p:cNvSpPr>
+            <a:spLocks noGrp="1"/>
+          </p:cNvSpPr>
+          <p:nvPr>
+            <p:ph idx="1"/>
           </p:nvPr>
         </p:nvSpPr>
         <p:spPr/>
@@ -3872,36 +4100,28 @@
           <a:lstStyle/>
           <a:p>
             <a:pPr lvl="0" indent="0" marL="0">
+              <a:spcBef>
+                <a:spcPts val="3000"/>
+              </a:spcBef>
               <a:buNone/>
             </a:pPr>
             <a:r>
+              <a:rPr b="1"/>
+              <a:t>Business Model</a:t>
+            </a:r>
+          </a:p>
+          <a:p>
+            <a:pPr lvl="0"/>
+            <a:r>
               <a:rPr/>
-              <a:t>The Ask</a:t>
-            </a:r>
-          </a:p>
-        </p:txBody>
-      </p:sp>
-      <p:sp>
-        <p:nvSpPr>
-          <p:cNvPr id="3" name="Content Placeholder 2"/>
-          <p:cNvSpPr>
-            <a:spLocks noGrp="1"/>
-          </p:cNvSpPr>
-          <p:nvPr>
-            <p:ph idx="1"/>
-          </p:nvPr>
-        </p:nvSpPr>
-        <p:spPr/>
-        <p:txBody>
-          <a:bodyPr/>
-          <a:lstStyle/>
-          <a:p>
-            <a:pPr lvl="0" indent="0" marL="0">
-              <a:buNone/>
-            </a:pPr>
+              <a:t>{‘Pay-per-chapter’: ‘$2.99 (5 pages), $9.99 (20 pages).’}</a:t>
+            </a:r>
+          </a:p>
+          <a:p>
+            <a:pPr lvl="0"/>
             <a:r>
               <a:rPr/>
-              <a:t>$15k in API or GPU credits, publisher intros, legal regulations advice.</a:t>
+              <a:t>Marketplace for style packs and publisher revenue sharing/licensing.</a:t>
             </a:r>
           </a:p>
         </p:txBody>

</xml_diff>